<commit_message>
All Fixes and updates done
</commit_message>
<xml_diff>
--- a/STTG_Presentation.pptx
+++ b/STTG_Presentation.pptx
@@ -5,7 +5,7 @@
     <p:sldMasterId id="2147483648" r:id="rId1"/>
   </p:sldMasterIdLst>
   <p:notesMasterIdLst>
-    <p:notesMasterId r:id="rId18"/>
+    <p:notesMasterId r:id="rId19"/>
   </p:notesMasterIdLst>
   <p:sldIdLst>
     <p:sldId id="257" r:id="rId2"/>
@@ -24,6 +24,7 @@
     <p:sldId id="270" r:id="rId15"/>
     <p:sldId id="266" r:id="rId16"/>
     <p:sldId id="272" r:id="rId17"/>
+    <p:sldId id="273" r:id="rId18"/>
   </p:sldIdLst>
   <p:sldSz cx="9144000" cy="6858000" type="screen4x3"/>
   <p:notesSz cx="6858000" cy="9144000"/>
@@ -7606,13 +7607,13 @@
           <a:p>
             <a:r>
               <a:rPr lang="en-IN" sz="2000" b="1" dirty="0"/>
-              <a:t>Guided By:</a:t>
+              <a:t>Internal Guide:</a:t>
             </a:r>
           </a:p>
           <a:p>
             <a:r>
               <a:rPr lang="en-IN" dirty="0"/>
-              <a:t>Dr. P. Jyothi ma’am</a:t>
+              <a:t>Mrs. Ch Sai Priya</a:t>
             </a:r>
           </a:p>
         </p:txBody>
@@ -7954,10 +7955,10 @@
       </p:sp>
       <p:pic>
         <p:nvPicPr>
-          <p:cNvPr id="5" name="Picture 4">
+          <p:cNvPr id="7" name="Picture 6">
             <a:extLst>
               <a:ext uri="{FF2B5EF4-FFF2-40B4-BE49-F238E27FC236}">
-                <a16:creationId xmlns:a16="http://schemas.microsoft.com/office/drawing/2014/main" id="{438995E8-94F9-1937-6E7E-85C3C7466ECC}"/>
+                <a16:creationId xmlns:a16="http://schemas.microsoft.com/office/drawing/2014/main" id="{4D6297B4-BA7C-57F2-3E0D-DA65485DD9A5}"/>
               </a:ext>
             </a:extLst>
           </p:cNvPr>
@@ -7980,8 +7981,8 @@
         </p:blipFill>
         <p:spPr>
           <a:xfrm>
-            <a:off x="1447800" y="1412722"/>
-            <a:ext cx="5181600" cy="5048486"/>
+            <a:off x="1752600" y="1600200"/>
+            <a:ext cx="4727337" cy="4517314"/>
           </a:xfrm>
           <a:prstGeom prst="rect">
             <a:avLst/>
@@ -8373,6 +8374,208 @@
     <p:extLst>
       <p:ext uri="{BB962C8B-B14F-4D97-AF65-F5344CB8AC3E}">
         <p14:creationId xmlns:p14="http://schemas.microsoft.com/office/powerpoint/2010/main" val="2606881219"/>
+      </p:ext>
+    </p:extLst>
+  </p:cSld>
+  <p:clrMapOvr>
+    <a:masterClrMapping/>
+  </p:clrMapOvr>
+</p:sld>
+</file>
+
+<file path=ppt/slides/slide17.xml><?xml version="1.0" encoding="utf-8"?>
+<p:sld xmlns:a="http://schemas.openxmlformats.org/drawingml/2006/main" xmlns:r="http://schemas.openxmlformats.org/officeDocument/2006/relationships" xmlns:p="http://schemas.openxmlformats.org/presentationml/2006/main">
+  <p:cSld>
+    <p:spTree>
+      <p:nvGrpSpPr>
+        <p:cNvPr id="1" name=""/>
+        <p:cNvGrpSpPr/>
+        <p:nvPr/>
+      </p:nvGrpSpPr>
+      <p:grpSpPr>
+        <a:xfrm>
+          <a:off x="0" y="0"/>
+          <a:ext cx="0" cy="0"/>
+          <a:chOff x="0" y="0"/>
+          <a:chExt cx="0" cy="0"/>
+        </a:xfrm>
+      </p:grpSpPr>
+      <p:sp>
+        <p:nvSpPr>
+          <p:cNvPr id="2" name="Title 1">
+            <a:extLst>
+              <a:ext uri="{FF2B5EF4-FFF2-40B4-BE49-F238E27FC236}">
+                <a16:creationId xmlns:a16="http://schemas.microsoft.com/office/drawing/2014/main" id="{1684574E-402F-1C3C-E60E-C69C9BB89582}"/>
+              </a:ext>
+            </a:extLst>
+          </p:cNvPr>
+          <p:cNvSpPr>
+            <a:spLocks noGrp="1"/>
+          </p:cNvSpPr>
+          <p:nvPr>
+            <p:ph type="title"/>
+          </p:nvPr>
+        </p:nvSpPr>
+        <p:spPr/>
+        <p:txBody>
+          <a:bodyPr/>
+          <a:lstStyle/>
+          <a:p>
+            <a:r>
+              <a:rPr lang="en-IN" dirty="0"/>
+              <a:t>Output</a:t>
+            </a:r>
+          </a:p>
+        </p:txBody>
+      </p:sp>
+      <p:pic>
+        <p:nvPicPr>
+          <p:cNvPr id="5" name="Picture 4">
+            <a:extLst>
+              <a:ext uri="{FF2B5EF4-FFF2-40B4-BE49-F238E27FC236}">
+                <a16:creationId xmlns:a16="http://schemas.microsoft.com/office/drawing/2014/main" id="{0E74E484-6F2D-7217-3B3F-A43ABDACE7CE}"/>
+              </a:ext>
+            </a:extLst>
+          </p:cNvPr>
+          <p:cNvPicPr>
+            <a:picLocks noChangeAspect="1"/>
+          </p:cNvPicPr>
+          <p:nvPr/>
+        </p:nvPicPr>
+        <p:blipFill>
+          <a:blip r:embed="rId2" cstate="print">
+            <a:extLst>
+              <a:ext uri="{28A0092B-C50C-407E-A947-70E740481C1C}">
+                <a14:useLocalDpi xmlns:a14="http://schemas.microsoft.com/office/drawing/2010/main" val="0"/>
+              </a:ext>
+            </a:extLst>
+          </a:blip>
+          <a:stretch>
+            <a:fillRect/>
+          </a:stretch>
+        </p:blipFill>
+        <p:spPr>
+          <a:xfrm>
+            <a:off x="457201" y="1635760"/>
+            <a:ext cx="3924634" cy="1793240"/>
+          </a:xfrm>
+          <a:prstGeom prst="rect">
+            <a:avLst/>
+          </a:prstGeom>
+        </p:spPr>
+      </p:pic>
+      <p:pic>
+        <p:nvPicPr>
+          <p:cNvPr id="7" name="Picture 6">
+            <a:extLst>
+              <a:ext uri="{FF2B5EF4-FFF2-40B4-BE49-F238E27FC236}">
+                <a16:creationId xmlns:a16="http://schemas.microsoft.com/office/drawing/2014/main" id="{B46F4113-3430-0F04-BC37-19EC6B11E2EF}"/>
+              </a:ext>
+            </a:extLst>
+          </p:cNvPr>
+          <p:cNvPicPr>
+            <a:picLocks noChangeAspect="1"/>
+          </p:cNvPicPr>
+          <p:nvPr/>
+        </p:nvPicPr>
+        <p:blipFill>
+          <a:blip r:embed="rId3" cstate="print">
+            <a:extLst>
+              <a:ext uri="{28A0092B-C50C-407E-A947-70E740481C1C}">
+                <a14:useLocalDpi xmlns:a14="http://schemas.microsoft.com/office/drawing/2010/main" val="0"/>
+              </a:ext>
+            </a:extLst>
+          </a:blip>
+          <a:stretch>
+            <a:fillRect/>
+          </a:stretch>
+        </p:blipFill>
+        <p:spPr>
+          <a:xfrm>
+            <a:off x="4639839" y="1635760"/>
+            <a:ext cx="3924634" cy="1795637"/>
+          </a:xfrm>
+          <a:prstGeom prst="rect">
+            <a:avLst/>
+          </a:prstGeom>
+        </p:spPr>
+      </p:pic>
+      <p:pic>
+        <p:nvPicPr>
+          <p:cNvPr id="9" name="Picture 8">
+            <a:extLst>
+              <a:ext uri="{FF2B5EF4-FFF2-40B4-BE49-F238E27FC236}">
+                <a16:creationId xmlns:a16="http://schemas.microsoft.com/office/drawing/2014/main" id="{0517E883-CB65-CEA9-8EA0-EC66FB05AA41}"/>
+              </a:ext>
+            </a:extLst>
+          </p:cNvPr>
+          <p:cNvPicPr>
+            <a:picLocks noChangeAspect="1"/>
+          </p:cNvPicPr>
+          <p:nvPr/>
+        </p:nvPicPr>
+        <p:blipFill>
+          <a:blip r:embed="rId4" cstate="print">
+            <a:extLst>
+              <a:ext uri="{28A0092B-C50C-407E-A947-70E740481C1C}">
+                <a14:useLocalDpi xmlns:a14="http://schemas.microsoft.com/office/drawing/2010/main" val="0"/>
+              </a:ext>
+            </a:extLst>
+          </a:blip>
+          <a:stretch>
+            <a:fillRect/>
+          </a:stretch>
+        </p:blipFill>
+        <p:spPr>
+          <a:xfrm>
+            <a:off x="452120" y="3682682"/>
+            <a:ext cx="3928342" cy="1793240"/>
+          </a:xfrm>
+          <a:prstGeom prst="rect">
+            <a:avLst/>
+          </a:prstGeom>
+        </p:spPr>
+      </p:pic>
+      <p:pic>
+        <p:nvPicPr>
+          <p:cNvPr id="11" name="Picture 10">
+            <a:extLst>
+              <a:ext uri="{FF2B5EF4-FFF2-40B4-BE49-F238E27FC236}">
+                <a16:creationId xmlns:a16="http://schemas.microsoft.com/office/drawing/2014/main" id="{CD7EFA9F-C08B-E089-44BF-2EB0BA41DDAF}"/>
+              </a:ext>
+            </a:extLst>
+          </p:cNvPr>
+          <p:cNvPicPr>
+            <a:picLocks noChangeAspect="1"/>
+          </p:cNvPicPr>
+          <p:nvPr/>
+        </p:nvPicPr>
+        <p:blipFill>
+          <a:blip r:embed="rId5" cstate="print">
+            <a:extLst>
+              <a:ext uri="{28A0092B-C50C-407E-A947-70E740481C1C}">
+                <a14:useLocalDpi xmlns:a14="http://schemas.microsoft.com/office/drawing/2010/main" val="0"/>
+              </a:ext>
+            </a:extLst>
+          </a:blip>
+          <a:stretch>
+            <a:fillRect/>
+          </a:stretch>
+        </p:blipFill>
+        <p:spPr>
+          <a:xfrm>
+            <a:off x="4653988" y="3682683"/>
+            <a:ext cx="3910485" cy="1793239"/>
+          </a:xfrm>
+          <a:prstGeom prst="rect">
+            <a:avLst/>
+          </a:prstGeom>
+        </p:spPr>
+      </p:pic>
+    </p:spTree>
+    <p:extLst>
+      <p:ext uri="{BB962C8B-B14F-4D97-AF65-F5344CB8AC3E}">
+        <p14:creationId xmlns:p14="http://schemas.microsoft.com/office/powerpoint/2010/main" val="2379048100"/>
       </p:ext>
     </p:extLst>
   </p:cSld>

</xml_diff>